<commit_message>
docs: Phase 6-7 status, deck and study material updated for look-ahead
</commit_message>
<xml_diff>
--- a/docs/LiftZero_Viva_Deck.pptx
+++ b/docs/LiftZero_Viva_Deck.pptx
@@ -1979,7 +1979,7 @@
           <a:p>
             <a:r>
               <a:rPr lang="en-US" dirty="0"/>
-              <a:t>Presenter: Akash. This is the designed next stage: the dispatcher, which sees all bids, runs a short look-ahead over contested decisions using the network as prior and value. It is not implemented yet — say so clearly and present the design and the formula.</a:t>
+              <a:t>Presenter: Akash. The dispatcher, which sees all bids, runs a short PUCT look-ahead over contested calls: about 22 simulations to depth 3 inside a 50 ms budget, sampled hidden passengers, cost-greedy rollouts. Demo it live on the Brain page (strategy LiftZero + look-ahead).</a:t>
             </a:r>
             <a:endParaRPr lang="en-US" dirty="0"/>
           </a:p>
@@ -4368,7 +4368,7 @@
                 <a:ea typeface="Calibri" pitchFamily="34" charset="-122"/>
                 <a:cs typeface="Calibri" pitchFamily="34" charset="-120"/>
               </a:rPr>
-              <a:t>Story mode</a:t>
+              <a:t>LiftZero Brain</a:t>
             </a:r>
             <a:endParaRPr lang="en-US" sz="1700" dirty="0"/>
           </a:p>
@@ -4407,7 +4407,7 @@
                 <a:ea typeface="Calibri" pitchFamily="34" charset="-122"/>
                 <a:cs typeface="Calibri" pitchFamily="34" charset="-120"/>
               </a:rPr>
-              <a:t>guided 10-beat walkthrough for examiners</a:t>
+              <a:t>live network bids, attention, search visits and Q, 'Why?' saliency</a:t>
             </a:r>
             <a:endParaRPr lang="en-US" sz="1400" dirty="0"/>
           </a:p>
@@ -6019,7 +6019,7 @@
                 <a:ea typeface="Calibri" pitchFamily="34" charset="-122"/>
                 <a:cs typeface="Calibri" pitchFamily="34" charset="-120"/>
               </a:rPr>
-              <a:t>Search design (PUCT-MCTS)</a:t>
+              <a:t>PUCT-MCTS look-ahead</a:t>
             </a:r>
             <a:endParaRPr lang="en-US" sz="1400" dirty="0"/>
           </a:p>
@@ -6696,7 +6696,7 @@
                 <a:ea typeface="Calibri" pitchFamily="34" charset="-122"/>
                 <a:cs typeface="Calibri" pitchFamily="34" charset="-120"/>
               </a:rPr>
-              <a:t>Complete PPO training on GPU and test against the teacher</a:t>
+              <a:t>Complete PPO training (code and tests ready) and compare with the teacher</a:t>
             </a:r>
             <a:endParaRPr lang="en-US" sz="1500" dirty="0"/>
           </a:p>
@@ -6717,7 +6717,7 @@
                 <a:ea typeface="Calibri" pitchFamily="34" charset="-122"/>
                 <a:cs typeface="Calibri" pitchFamily="34" charset="-120"/>
               </a:rPr>
-              <a:t>Implement PUCT look-ahead for contested calls</a:t>
+              <a:t>Tune the look-ahead budget; value-head leaves once PPO is trained</a:t>
             </a:r>
             <a:endParaRPr lang="en-US" sz="1500" dirty="0"/>
           </a:p>
@@ -12757,7 +12757,7 @@
                 <a:ea typeface="Calibri" pitchFamily="34" charset="-122"/>
                 <a:cs typeface="Calibri" pitchFamily="34" charset="-120"/>
               </a:rPr>
-              <a:t>Status: designed, not yet implemented</a:t>
+              <a:t>Implemented: live in the Brain panel</a:t>
             </a:r>
             <a:endParaRPr lang="en-US" sz="1700" dirty="0"/>
           </a:p>
@@ -12796,7 +12796,7 @@
                 <a:ea typeface="Calibri" pitchFamily="34" charset="-122"/>
                 <a:cs typeface="Calibri" pitchFamily="34" charset="-120"/>
               </a:rPr>
-              <a:t>The reflex learner (bids) and the deliberative planner (search) form the AIMA contrast between reflex and model-based agents in one system.</a:t>
+              <a:t>~22 simulations to depth 3 in a 50 ms budget; searches ~70 % of auctions and overrides the network on ~15–20 % of them, with zero safety violations.</a:t>
             </a:r>
             <a:endParaRPr lang="en-US" sz="1500" dirty="0"/>
           </a:p>

</xml_diff>